<commit_message>
Renumber steps in Chat.Console and update PPTX
Adjust step indices and ConsoleHelper messages in Chat.Console/Program.cs to correct the progress sequence (renumbered comments and status outputs for steps 1–7). No functional logic changes to query or processing flow. Also include an updated Presentation.pptx (binary slide update).
</commit_message>
<xml_diff>
--- a/Presentation.pptx
+++ b/Presentation.pptx
@@ -217,7 +217,7 @@
           <a:p>
             <a:fld id="{BC660078-77E7-46A7-9649-B3FD62DAD7B9}" type="datetimeFigureOut">
               <a:rPr lang="tr-TR" smtClean="0"/>
-              <a:t>29.04.2026</a:t>
+              <a:t>30.04.2026</a:t>
             </a:fld>
             <a:endParaRPr lang="tr-TR"/>
           </a:p>
@@ -576,8 +576,209 @@
           <a:p>
             <a:r>
               <a:rPr lang="en-US" dirty="0"/>
-              <a:t>[TRANSITION] 'That's exactly the problem we're solving.'</a:t>
-            </a:r>
+              <a:t>[TRANSITION] 'That's exactly the problem we're solving.’</a:t>
+            </a:r>
+          </a:p>
+          <a:p>
+            <a:r>
+              <a:rPr lang="en-US"/>
+              <a:t>//////////////////////////</a:t>
+            </a:r>
+            <a:endParaRPr lang="en-US" dirty="0"/>
+          </a:p>
+          <a:p>
+            <a:endParaRPr lang="en-US" dirty="0"/>
+          </a:p>
+          <a:p>
+            <a:r>
+              <a:rPr lang="en-US" dirty="0"/>
+              <a:t>5. slide </a:t>
+            </a:r>
+            <a:r>
+              <a:rPr lang="en-US" dirty="0" err="1"/>
+              <a:t>sil</a:t>
+            </a:r>
+            <a:endParaRPr lang="en-US" dirty="0"/>
+          </a:p>
+          <a:p>
+            <a:r>
+              <a:rPr lang="en-US" dirty="0"/>
+              <a:t>6. </a:t>
+            </a:r>
+            <a:r>
+              <a:rPr lang="en-US" dirty="0" err="1"/>
+              <a:t>sil</a:t>
+            </a:r>
+            <a:endParaRPr lang="en-US" dirty="0"/>
+          </a:p>
+          <a:p>
+            <a:r>
+              <a:rPr lang="en-US" dirty="0"/>
+              <a:t>8. daha </a:t>
+            </a:r>
+            <a:r>
+              <a:rPr lang="en-US" dirty="0" err="1"/>
+              <a:t>az</a:t>
+            </a:r>
+            <a:r>
+              <a:rPr lang="en-US" dirty="0"/>
+              <a:t> zaman</a:t>
+            </a:r>
+          </a:p>
+          <a:p>
+            <a:r>
+              <a:rPr lang="en-US" dirty="0"/>
+              <a:t>9. </a:t>
+            </a:r>
+            <a:r>
+              <a:rPr lang="en-US" dirty="0" err="1"/>
+              <a:t>ile</a:t>
+            </a:r>
+            <a:r>
+              <a:rPr lang="en-US" dirty="0"/>
+              <a:t> 6. </a:t>
+            </a:r>
+            <a:r>
+              <a:rPr lang="en-US" dirty="0" err="1"/>
+              <a:t>yer</a:t>
+            </a:r>
+            <a:r>
+              <a:rPr lang="en-US" dirty="0"/>
+              <a:t> </a:t>
+            </a:r>
+            <a:r>
+              <a:rPr lang="en-US" dirty="0" err="1"/>
+              <a:t>değiştir</a:t>
+            </a:r>
+            <a:endParaRPr lang="en-US" dirty="0"/>
+          </a:p>
+          <a:p>
+            <a:r>
+              <a:rPr lang="en-US" dirty="0"/>
+              <a:t>12. 15. 16. 17. </a:t>
+            </a:r>
+            <a:r>
+              <a:rPr lang="en-US" dirty="0" err="1"/>
+              <a:t>sil</a:t>
+            </a:r>
+            <a:endParaRPr lang="en-US" dirty="0"/>
+          </a:p>
+          <a:p>
+            <a:endParaRPr lang="en-US" dirty="0"/>
+          </a:p>
+          <a:p>
+            <a:endParaRPr lang="en-US" dirty="0"/>
+          </a:p>
+          <a:p>
+            <a:r>
+              <a:rPr lang="en-US" dirty="0"/>
+              <a:t>7 slide 10sn </a:t>
+            </a:r>
+            <a:r>
+              <a:rPr lang="en-US" dirty="0" err="1"/>
+              <a:t>göster</a:t>
+            </a:r>
+            <a:endParaRPr lang="en-US" dirty="0"/>
+          </a:p>
+          <a:p>
+            <a:r>
+              <a:rPr lang="en-US" dirty="0" err="1"/>
+              <a:t>sunum</a:t>
+            </a:r>
+            <a:r>
+              <a:rPr lang="en-US" dirty="0"/>
+              <a:t> </a:t>
+            </a:r>
+            <a:r>
+              <a:rPr lang="en-US" dirty="0" err="1"/>
+              <a:t>tarafını</a:t>
+            </a:r>
+            <a:r>
+              <a:rPr lang="en-US" dirty="0"/>
+              <a:t> </a:t>
+            </a:r>
+            <a:r>
+              <a:rPr lang="en-US" dirty="0" err="1"/>
+              <a:t>mümkün</a:t>
+            </a:r>
+            <a:r>
+              <a:rPr lang="en-US" dirty="0"/>
+              <a:t> </a:t>
+            </a:r>
+            <a:r>
+              <a:rPr lang="en-US" dirty="0" err="1"/>
+              <a:t>olduğunca</a:t>
+            </a:r>
+            <a:r>
+              <a:rPr lang="en-US" dirty="0"/>
+              <a:t> </a:t>
+            </a:r>
+            <a:r>
+              <a:rPr lang="en-US" dirty="0" err="1"/>
+              <a:t>azalt</a:t>
+            </a:r>
+            <a:endParaRPr lang="en-US" dirty="0"/>
+          </a:p>
+          <a:p>
+            <a:r>
+              <a:rPr lang="en-US" dirty="0"/>
+              <a:t>console </a:t>
+            </a:r>
+            <a:r>
+              <a:rPr lang="en-US" dirty="0" err="1"/>
+              <a:t>uygulamasını</a:t>
+            </a:r>
+            <a:r>
+              <a:rPr lang="en-US" dirty="0"/>
+              <a:t> 1 </a:t>
+            </a:r>
+            <a:r>
+              <a:rPr lang="en-US" dirty="0" err="1"/>
+              <a:t>kez</a:t>
+            </a:r>
+            <a:r>
+              <a:rPr lang="en-US" dirty="0"/>
+              <a:t> </a:t>
+            </a:r>
+            <a:r>
+              <a:rPr lang="en-US" dirty="0" err="1"/>
+              <a:t>çalıştır</a:t>
+            </a:r>
+            <a:endParaRPr lang="en-US" dirty="0"/>
+          </a:p>
+          <a:p>
+            <a:r>
+              <a:rPr lang="en-US" dirty="0" err="1"/>
+              <a:t>soru</a:t>
+            </a:r>
+            <a:r>
+              <a:rPr lang="en-US" dirty="0"/>
+              <a:t> </a:t>
+            </a:r>
+            <a:r>
+              <a:rPr lang="en-US" dirty="0" err="1"/>
+              <a:t>seçimlerini</a:t>
+            </a:r>
+            <a:r>
+              <a:rPr lang="en-US" dirty="0"/>
+              <a:t> </a:t>
+            </a:r>
+            <a:r>
+              <a:rPr lang="en-US" dirty="0" err="1"/>
+              <a:t>baştan</a:t>
+            </a:r>
+            <a:r>
+              <a:rPr lang="en-US" dirty="0"/>
+              <a:t> </a:t>
+            </a:r>
+            <a:r>
+              <a:rPr lang="en-US" dirty="0" err="1"/>
+              <a:t>ayarla</a:t>
+            </a:r>
+            <a:endParaRPr lang="en-US" dirty="0"/>
+          </a:p>
+          <a:p>
+            <a:endParaRPr lang="en-US" dirty="0"/>
           </a:p>
         </p:txBody>
       </p:sp>
@@ -3182,7 +3383,7 @@
           <a:p>
             <a:fld id="{3EF59CCF-2F75-48E0-B827-F930E918C137}" type="datetimeFigureOut">
               <a:rPr lang="tr-TR" smtClean="0"/>
-              <a:t>29.04.2026</a:t>
+              <a:t>30.04.2026</a:t>
             </a:fld>
             <a:endParaRPr lang="tr-TR"/>
           </a:p>
@@ -3382,7 +3583,7 @@
           <a:p>
             <a:fld id="{3EF59CCF-2F75-48E0-B827-F930E918C137}" type="datetimeFigureOut">
               <a:rPr lang="tr-TR" smtClean="0"/>
-              <a:t>29.04.2026</a:t>
+              <a:t>30.04.2026</a:t>
             </a:fld>
             <a:endParaRPr lang="tr-TR"/>
           </a:p>
@@ -3592,7 +3793,7 @@
           <a:p>
             <a:fld id="{3EF59CCF-2F75-48E0-B827-F930E918C137}" type="datetimeFigureOut">
               <a:rPr lang="tr-TR" smtClean="0"/>
-              <a:t>29.04.2026</a:t>
+              <a:t>30.04.2026</a:t>
             </a:fld>
             <a:endParaRPr lang="tr-TR"/>
           </a:p>
@@ -3792,7 +3993,7 @@
           <a:p>
             <a:fld id="{3EF59CCF-2F75-48E0-B827-F930E918C137}" type="datetimeFigureOut">
               <a:rPr lang="tr-TR" smtClean="0"/>
-              <a:t>29.04.2026</a:t>
+              <a:t>30.04.2026</a:t>
             </a:fld>
             <a:endParaRPr lang="tr-TR"/>
           </a:p>
@@ -4068,7 +4269,7 @@
           <a:p>
             <a:fld id="{3EF59CCF-2F75-48E0-B827-F930E918C137}" type="datetimeFigureOut">
               <a:rPr lang="tr-TR" smtClean="0"/>
-              <a:t>29.04.2026</a:t>
+              <a:t>30.04.2026</a:t>
             </a:fld>
             <a:endParaRPr lang="tr-TR"/>
           </a:p>
@@ -4336,7 +4537,7 @@
           <a:p>
             <a:fld id="{3EF59CCF-2F75-48E0-B827-F930E918C137}" type="datetimeFigureOut">
               <a:rPr lang="tr-TR" smtClean="0"/>
-              <a:t>29.04.2026</a:t>
+              <a:t>30.04.2026</a:t>
             </a:fld>
             <a:endParaRPr lang="tr-TR"/>
           </a:p>
@@ -4751,7 +4952,7 @@
           <a:p>
             <a:fld id="{3EF59CCF-2F75-48E0-B827-F930E918C137}" type="datetimeFigureOut">
               <a:rPr lang="tr-TR" smtClean="0"/>
-              <a:t>29.04.2026</a:t>
+              <a:t>30.04.2026</a:t>
             </a:fld>
             <a:endParaRPr lang="tr-TR"/>
           </a:p>
@@ -4893,7 +5094,7 @@
           <a:p>
             <a:fld id="{3EF59CCF-2F75-48E0-B827-F930E918C137}" type="datetimeFigureOut">
               <a:rPr lang="tr-TR" smtClean="0"/>
-              <a:t>29.04.2026</a:t>
+              <a:t>30.04.2026</a:t>
             </a:fld>
             <a:endParaRPr lang="tr-TR"/>
           </a:p>
@@ -5006,7 +5207,7 @@
           <a:p>
             <a:fld id="{3EF59CCF-2F75-48E0-B827-F930E918C137}" type="datetimeFigureOut">
               <a:rPr lang="tr-TR" smtClean="0"/>
-              <a:t>29.04.2026</a:t>
+              <a:t>30.04.2026</a:t>
             </a:fld>
             <a:endParaRPr lang="tr-TR"/>
           </a:p>
@@ -5319,7 +5520,7 @@
           <a:p>
             <a:fld id="{3EF59CCF-2F75-48E0-B827-F930E918C137}" type="datetimeFigureOut">
               <a:rPr lang="tr-TR" smtClean="0"/>
-              <a:t>29.04.2026</a:t>
+              <a:t>30.04.2026</a:t>
             </a:fld>
             <a:endParaRPr lang="tr-TR"/>
           </a:p>
@@ -5608,7 +5809,7 @@
           <a:p>
             <a:fld id="{3EF59CCF-2F75-48E0-B827-F930E918C137}" type="datetimeFigureOut">
               <a:rPr lang="tr-TR" smtClean="0"/>
-              <a:t>29.04.2026</a:t>
+              <a:t>30.04.2026</a:t>
             </a:fld>
             <a:endParaRPr lang="tr-TR"/>
           </a:p>
@@ -5854,7 +6055,7 @@
           <a:p>
             <a:fld id="{3EF59CCF-2F75-48E0-B827-F930E918C137}" type="datetimeFigureOut">
               <a:rPr lang="tr-TR" smtClean="0"/>
-              <a:t>29.04.2026</a:t>
+              <a:t>30.04.2026</a:t>
             </a:fld>
             <a:endParaRPr lang="tr-TR"/>
           </a:p>
@@ -8631,8 +8832,8 @@
         </p:nvSpPr>
         <p:spPr>
           <a:xfrm>
-            <a:off x="635000" y="1651000"/>
-            <a:ext cx="10515600" cy="4064000"/>
+            <a:off x="635000" y="1940367"/>
+            <a:ext cx="10515600" cy="3355051"/>
           </a:xfrm>
           <a:prstGeom prst="roundRect">
             <a:avLst>
@@ -8801,40 +9002,6 @@
                 <a:latin typeface="Consolas"/>
               </a:rPr>
               <a:t>}</a:t>
-            </a:r>
-          </a:p>
-          <a:p>
-            <a:pPr>
-              <a:spcBef>
-                <a:spcPts val="200"/>
-              </a:spcBef>
-            </a:pPr>
-            <a:r>
-              <a:rPr lang="en-US" sz="3200" dirty="0">
-                <a:solidFill>
-                  <a:srgbClr val="E2E8F0"/>
-                </a:solidFill>
-                <a:latin typeface="Consolas"/>
-              </a:rPr>
-              <a:t>    opt.ReadOnly      = </a:t>
-            </a:r>
-            <a:r>
-              <a:rPr lang="en-US" sz="3200" dirty="0">
-                <a:solidFill>
-                  <a:srgbClr val="A78BFA"/>
-                </a:solidFill>
-                <a:latin typeface="Consolas"/>
-              </a:rPr>
-              <a:t>true</a:t>
-            </a:r>
-            <a:r>
-              <a:rPr lang="en-US" sz="3200" dirty="0">
-                <a:solidFill>
-                  <a:srgbClr val="E2E8F0"/>
-                </a:solidFill>
-                <a:latin typeface="Consolas"/>
-              </a:rPr>
-              <a:t>; //optional</a:t>
             </a:r>
           </a:p>
           <a:p>
@@ -10758,7 +10925,7 @@
         </p:nvSpPr>
         <p:spPr>
           <a:xfrm>
-            <a:off x="562430" y="1651000"/>
+            <a:off x="562430" y="1853554"/>
             <a:ext cx="3600000" cy="1944000"/>
           </a:xfrm>
           <a:prstGeom prst="roundRect">
@@ -10822,7 +10989,7 @@
         </p:nvSpPr>
         <p:spPr>
           <a:xfrm>
-            <a:off x="4236525" y="1651000"/>
+            <a:off x="4236525" y="1853554"/>
             <a:ext cx="3600000" cy="1944000"/>
           </a:xfrm>
           <a:prstGeom prst="roundRect">
@@ -10886,7 +11053,7 @@
         </p:nvSpPr>
         <p:spPr>
           <a:xfrm>
-            <a:off x="7910620" y="1651000"/>
+            <a:off x="7910620" y="1853554"/>
             <a:ext cx="3600000" cy="1944000"/>
           </a:xfrm>
           <a:prstGeom prst="roundRect">
@@ -10950,7 +11117,7 @@
         </p:nvSpPr>
         <p:spPr>
           <a:xfrm>
-            <a:off x="562430" y="3643417"/>
+            <a:off x="562430" y="4094829"/>
             <a:ext cx="3600000" cy="1944000"/>
           </a:xfrm>
           <a:prstGeom prst="roundRect">
@@ -11014,7 +11181,7 @@
         </p:nvSpPr>
         <p:spPr>
           <a:xfrm>
-            <a:off x="4236525" y="3643417"/>
+            <a:off x="4236525" y="4094829"/>
             <a:ext cx="3600000" cy="1944000"/>
           </a:xfrm>
           <a:prstGeom prst="roundRect">
@@ -11086,7 +11253,7 @@
         </p:nvSpPr>
         <p:spPr>
           <a:xfrm>
-            <a:off x="7910620" y="3643417"/>
+            <a:off x="7910620" y="4094829"/>
             <a:ext cx="3600000" cy="1944000"/>
           </a:xfrm>
           <a:prstGeom prst="roundRect">
@@ -11138,59 +11305,6 @@
                 </a:solidFill>
               </a:rPr>
               <a:t>"Top 20 SKUs by margin this year."</a:t>
-            </a:r>
-          </a:p>
-        </p:txBody>
-      </p:sp>
-      <p:sp>
-        <p:nvSpPr>
-          <p:cNvPr id="3" name="BQ">
-            <a:extLst>
-              <a:ext uri="{FF2B5EF4-FFF2-40B4-BE49-F238E27FC236}">
-                <a16:creationId xmlns:a16="http://schemas.microsoft.com/office/drawing/2014/main" id="{3922238F-AA9D-112C-25C6-0B9544A29EDE}"/>
-              </a:ext>
-            </a:extLst>
-          </p:cNvPr>
-          <p:cNvSpPr/>
-          <p:nvPr/>
-        </p:nvSpPr>
-        <p:spPr>
-          <a:xfrm>
-            <a:off x="843147" y="5388429"/>
-            <a:ext cx="10307453" cy="927430"/>
-          </a:xfrm>
-          <a:prstGeom prst="roundRect">
-            <a:avLst>
-              <a:gd name="adj" fmla="val 50000"/>
-            </a:avLst>
-          </a:prstGeom>
-          <a:solidFill>
-            <a:srgbClr val="F1F5F9"/>
-          </a:solidFill>
-          <a:ln>
-            <a:noFill/>
-          </a:ln>
-        </p:spPr>
-        <p:txBody>
-          <a:bodyPr wrap="square" lIns="180000" tIns="0" rIns="180000" bIns="0" anchor="ctr"/>
-          <a:lstStyle/>
-          <a:p>
-            <a:pPr algn="ctr"/>
-            <a:r>
-              <a:rPr lang="en-US" sz="2400" b="1" dirty="0">
-                <a:solidFill>
-                  <a:srgbClr val="475569"/>
-                </a:solidFill>
-              </a:rPr>
-              <a:t>Hold-on!</a:t>
-            </a:r>
-            <a:r>
-              <a:rPr lang="en-US" sz="2400" dirty="0">
-                <a:solidFill>
-                  <a:srgbClr val="475569"/>
-                </a:solidFill>
-              </a:rPr>
-              <a:t> How about actual works instead of just reporting!</a:t>
             </a:r>
           </a:p>
         </p:txBody>

</xml_diff>

<commit_message>
Add pre-talk notes and updated presentation
Add Before-Talk.txt containing preparatory questions and local paths for the talk. Update Presentation.pptx (binary changes) and add Presentation_revised.pptx as a revised slide deck. The text file captures analytics/reporting questions to drive the revised presentation.
</commit_message>
<xml_diff>
--- a/Presentation.pptx
+++ b/Presentation.pptx
@@ -2474,70 +2474,146 @@
               <a:defRPr/>
             </a:pPr>
             <a:r>
-              <a:rPr lang="en-US" sz="1200" i="1" dirty="0">
-                <a:solidFill>
-                  <a:srgbClr val="0891B2"/>
-                </a:solidFill>
-              </a:rPr>
-              <a:t>Now imagine your PM doing that… </a:t>
-            </a:r>
-            <a:r>
-              <a:rPr lang="en-US" sz="1200" b="1" i="1" dirty="0">
-                <a:solidFill>
-                  <a:srgbClr val="0891B2"/>
-                </a:solidFill>
-              </a:rPr>
-              <a:t>without you</a:t>
-            </a:r>
-            <a:r>
-              <a:rPr lang="en-US" sz="1200" i="1" dirty="0">
-                <a:solidFill>
-                  <a:srgbClr val="0891B2"/>
-                </a:solidFill>
-              </a:rPr>
-              <a:t>.</a:t>
-            </a:r>
-          </a:p>
-          <a:p>
+              <a:rPr lang="en-US" sz="1200" b="1" dirty="0">
+                <a:solidFill>
+                  <a:srgbClr val="0F172A"/>
+                </a:solidFill>
+                <a:sym typeface="Wingdings" panose="05000000000000000000" pitchFamily="2" charset="2"/>
+              </a:rPr>
+              <a:t> </a:t>
+            </a:r>
+            <a:r>
+              <a:rPr lang="en-US" sz="1200" b="1" dirty="0">
+                <a:solidFill>
+                  <a:srgbClr val="0F172A"/>
+                </a:solidFill>
+              </a:rPr>
+              <a:t>How many of you have written SQL before?</a:t>
+            </a:r>
+          </a:p>
+          <a:p>
+            <a:pPr marL="0" marR="0" lvl="0" indent="0" algn="l" defTabSz="914400" rtl="0" eaLnBrk="1" fontAlgn="auto" latinLnBrk="0" hangingPunct="1">
+              <a:lnSpc>
+                <a:spcPct val="100000"/>
+              </a:lnSpc>
+              <a:spcBef>
+                <a:spcPts val="0"/>
+              </a:spcBef>
+              <a:spcAft>
+                <a:spcPts val="0"/>
+              </a:spcAft>
+              <a:buClrTx/>
+              <a:buSzTx/>
+              <a:buFontTx/>
+              <a:buNone/>
+              <a:tabLst/>
+              <a:defRPr/>
+            </a:pPr>
             <a:endParaRPr lang="en-US" dirty="0"/>
           </a:p>
           <a:p>
-            <a:r>
-              <a:rPr lang="en-US" dirty="0"/>
-              <a:t>Walk them through each pain point briefly — don't read every word on the slide, just tap each one:</a:t>
-            </a:r>
-          </a:p>
-          <a:p>
+            <a:pPr marL="0" marR="0" lvl="0" indent="0" algn="l" defTabSz="914400" rtl="0" eaLnBrk="1" fontAlgn="auto" latinLnBrk="0" hangingPunct="1">
+              <a:lnSpc>
+                <a:spcPct val="100000"/>
+              </a:lnSpc>
+              <a:spcBef>
+                <a:spcPts val="0"/>
+              </a:spcBef>
+              <a:spcAft>
+                <a:spcPts val="0"/>
+              </a:spcAft>
+              <a:buClrTx/>
+              <a:buSzTx/>
+              <a:buFontTx/>
+              <a:buNone/>
+              <a:tabLst/>
+              <a:defRPr/>
+            </a:pPr>
+            <a:r>
+              <a:rPr lang="en-US" dirty="0"/>
+              <a:t>1. Traditional BI tools are rigid — every new question needs a new report</a:t>
+            </a:r>
+          </a:p>
+          <a:p>
+            <a:pPr marL="0" marR="0" lvl="0" indent="0" algn="l" defTabSz="914400" rtl="0" eaLnBrk="1" fontAlgn="auto" latinLnBrk="0" hangingPunct="1">
+              <a:lnSpc>
+                <a:spcPct val="100000"/>
+              </a:lnSpc>
+              <a:spcBef>
+                <a:spcPts val="0"/>
+              </a:spcBef>
+              <a:spcAft>
+                <a:spcPts val="0"/>
+              </a:spcAft>
+              <a:buClrTx/>
+              <a:buSzTx/>
+              <a:buFontTx/>
+              <a:buNone/>
+              <a:tabLst/>
+              <a:defRPr/>
+            </a:pPr>
+            <a:r>
+              <a:rPr lang="en-US" dirty="0"/>
+              <a:t>2. </a:t>
+            </a:r>
+          </a:p>
+          <a:p>
+            <a:pPr marL="0" marR="0" lvl="0" indent="0" algn="l" defTabSz="914400" rtl="0" eaLnBrk="1" fontAlgn="auto" latinLnBrk="0" hangingPunct="1">
+              <a:lnSpc>
+                <a:spcPct val="100000"/>
+              </a:lnSpc>
+              <a:spcBef>
+                <a:spcPts val="0"/>
+              </a:spcBef>
+              <a:spcAft>
+                <a:spcPts val="0"/>
+              </a:spcAft>
+              <a:buClrTx/>
+              <a:buSzTx/>
+              <a:buFontTx/>
+              <a:buNone/>
+              <a:tabLst/>
+              <a:defRPr/>
+            </a:pPr>
+            <a:r>
+              <a:rPr lang="en-US" dirty="0"/>
+              <a:t>- Business users wait days for answers they could have in seconds</a:t>
+            </a:r>
+          </a:p>
+          <a:p>
+            <a:pPr marL="0" indent="0">
+              <a:buFontTx/>
+              <a:buNone/>
+            </a:pPr>
             <a:r>
               <a:rPr lang="en-US" dirty="0"/>
               <a:t>- SQL is slow to write, especially for ad-hoc questions</a:t>
             </a:r>
           </a:p>
           <a:p>
-            <a:r>
-              <a:rPr lang="en-US" dirty="0"/>
-              <a:t>- Business users wait days for answers they could have in seconds</a:t>
-            </a:r>
-          </a:p>
-          <a:p>
-            <a:r>
-              <a:rPr lang="en-US" dirty="0"/>
-              <a:t>- Traditional BI tools are rigid — every new question needs a new report</a:t>
-            </a:r>
-          </a:p>
-          <a:p>
-            <a:r>
-              <a:rPr lang="en-US" dirty="0"/>
-              <a:t>- And the result: data is locked behind technical gatekeepers</a:t>
-            </a:r>
-          </a:p>
-          <a:p>
+            <a:pPr marL="0" indent="0">
+              <a:buFontTx/>
+              <a:buNone/>
+            </a:pPr>
+            <a:r>
+              <a:rPr lang="en-US" dirty="0"/>
+              <a:t>- Test, Deployment needs after new report screen.</a:t>
+            </a:r>
+          </a:p>
+          <a:p>
+            <a:pPr marL="0" indent="0">
+              <a:buFontTx/>
+              <a:buNone/>
+            </a:pPr>
             <a:endParaRPr lang="en-US" dirty="0"/>
           </a:p>
           <a:p>
-            <a:r>
-              <a:rPr lang="en-US" dirty="0"/>
-              <a:t>[EMPHASIZE] 'We are the bottleneck. And today we are going to remove ourselves.'</a:t>
+            <a:endParaRPr lang="en-US" dirty="0"/>
+          </a:p>
+          <a:p>
+            <a:r>
+              <a:rPr lang="en-US" b="1" dirty="0"/>
+              <a:t>We, developers are the bottleneck. And today we are going to remove ourselves.</a:t>
             </a:r>
           </a:p>
           <a:p>
@@ -9306,7 +9382,7 @@
         <p:spPr>
           <a:xfrm>
             <a:off x="1016000" y="1875027"/>
-            <a:ext cx="2930596" cy="558799"/>
+            <a:ext cx="5270500" cy="558799"/>
           </a:xfrm>
           <a:prstGeom prst="rect">
             <a:avLst/>
@@ -9314,7 +9390,7 @@
         </p:spPr>
         <p:txBody>
           <a:bodyPr>
-            <a:normAutofit/>
+            <a:normAutofit fontScale="92500"/>
           </a:bodyPr>
           <a:lstStyle>
             <a:lvl1pPr marL="228600" indent="-228600" algn="l" defTabSz="914400" rtl="0" eaLnBrk="1" latinLnBrk="0" hangingPunct="1">
@@ -9491,7 +9567,7 @@
                   <a:srgbClr val="22D3EE"/>
                 </a:solidFill>
               </a:rPr>
-              <a:t>PART 2</a:t>
+              <a:t>TALK TO YOUR DATA</a:t>
             </a:r>
           </a:p>
         </p:txBody>
@@ -9510,8 +9586,8 @@
         </p:nvSpPr>
         <p:spPr>
           <a:xfrm>
-            <a:off x="1114631" y="1784351"/>
-            <a:ext cx="1224000" cy="76200"/>
+            <a:off x="1095581" y="1784351"/>
+            <a:ext cx="4860000" cy="76200"/>
           </a:xfrm>
           <a:prstGeom prst="rect">
             <a:avLst/>
@@ -12767,7 +12843,7 @@
         </p:nvSpPr>
         <p:spPr>
           <a:xfrm>
-            <a:off x="73026" y="2612571"/>
+            <a:off x="73026" y="2822121"/>
             <a:ext cx="12118974" cy="3064329"/>
           </a:xfrm>
           <a:prstGeom prst="rect">
@@ -12802,8 +12878,8 @@
         </p:nvSpPr>
         <p:spPr>
           <a:xfrm>
-            <a:off x="407987" y="1266825"/>
-            <a:ext cx="11376025" cy="1219200"/>
+            <a:off x="444500" y="566738"/>
+            <a:ext cx="11376025" cy="2255383"/>
           </a:xfrm>
           <a:prstGeom prst="rect">
             <a:avLst/>
@@ -12820,34 +12896,36 @@
               </a:lnSpc>
             </a:pPr>
             <a:r>
-              <a:rPr lang="en-US" sz="7200" b="1" dirty="0">
+              <a:rPr lang="en-US" sz="6000" b="1" dirty="0">
                 <a:solidFill>
                   <a:srgbClr val="0F172A"/>
                 </a:solidFill>
               </a:rPr>
-              <a:t>1 step </a:t>
-            </a:r>
-            <a:r>
-              <a:rPr lang="en-US" sz="7200" b="1">
+              <a:t>If we used 100% of our </a:t>
+            </a:r>
+            <a:br>
+              <a:rPr lang="en-US" sz="6000" b="1" dirty="0">
                 <a:solidFill>
                   <a:srgbClr val="0F172A"/>
                 </a:solidFill>
               </a:rPr>
-              <a:t>further </a:t>
-            </a:r>
-            <a:r>
-              <a:rPr lang="en-US" sz="6600" b="1">
+            </a:br>
+            <a:r>
+              <a:rPr lang="en-US" sz="6000" b="1" dirty="0">
                 <a:solidFill>
                   <a:srgbClr val="0F172A"/>
                 </a:solidFill>
               </a:rPr>
+              <a:t>DB’s potential</a:t>
+            </a:r>
+            <a:r>
+              <a:rPr lang="en-US" sz="5400" b="1" dirty="0">
+                <a:solidFill>
+                  <a:srgbClr val="0F172A"/>
+                </a:solidFill>
+              </a:rPr>
               <a:t>🤔</a:t>
             </a:r>
-            <a:endParaRPr lang="en-US" sz="6600" b="1" dirty="0">
-              <a:solidFill>
-                <a:srgbClr val="0F172A"/>
-              </a:solidFill>
-            </a:endParaRPr>
           </a:p>
         </p:txBody>
       </p:sp>
@@ -12865,7 +12943,7 @@
         </p:nvSpPr>
         <p:spPr>
           <a:xfrm>
-            <a:off x="444500" y="2881312"/>
+            <a:off x="444500" y="3090862"/>
             <a:ext cx="11376025" cy="2400300"/>
           </a:xfrm>
           <a:prstGeom prst="rect">
@@ -12883,28 +12961,35 @@
               </a:lnSpc>
             </a:pPr>
             <a:r>
+              <a:rPr lang="en-US" sz="6600" b="1" u="sng" dirty="0">
+                <a:solidFill>
+                  <a:srgbClr val="FFFFFF"/>
+                </a:solidFill>
+              </a:rPr>
+              <a:t>Taking actions</a:t>
+            </a:r>
+            <a:r>
               <a:rPr lang="en-US" sz="6600" b="1" dirty="0">
                 <a:solidFill>
                   <a:srgbClr val="FFFFFF"/>
                 </a:solidFill>
               </a:rPr>
-              <a:t>How about </a:t>
-            </a:r>
-            <a:r>
-              <a:rPr lang="en-US" sz="6600" b="1" u="sng" dirty="0">
+              <a:t> </a:t>
+            </a:r>
+            <a:br>
+              <a:rPr lang="en-US" sz="6600" b="1" dirty="0">
                 <a:solidFill>
                   <a:srgbClr val="FFFFFF"/>
                 </a:solidFill>
               </a:rPr>
-              <a:t>taking action</a:t>
-            </a:r>
+            </a:br>
             <a:r>
               <a:rPr lang="en-US" sz="6600" b="1" dirty="0">
                 <a:solidFill>
                   <a:srgbClr val="FFFFFF"/>
                 </a:solidFill>
               </a:rPr>
-              <a:t> instead of just reporting?!</a:t>
+              <a:t>instead of just reporting!</a:t>
             </a:r>
           </a:p>
         </p:txBody>
@@ -13610,8 +13695,8 @@
         </p:nvSpPr>
         <p:spPr>
           <a:xfrm>
-            <a:off x="889000" y="1460500"/>
-            <a:ext cx="10414000" cy="1397000"/>
+            <a:off x="9129251" y="1650540"/>
+            <a:ext cx="2767779" cy="3983344"/>
           </a:xfrm>
           <a:prstGeom prst="roundRect">
             <a:avLst>
@@ -13631,28 +13716,44 @@
           <a:bodyPr wrap="square" lIns="260000" tIns="140000" rIns="260000" bIns="140000" anchor="ctr"/>
           <a:lstStyle/>
           <a:p>
-            <a:pPr algn="l"/>
-            <a:r>
-              <a:rPr lang="en-US" sz="2800" b="1" dirty="0">
+            <a:pPr algn="r"/>
+            <a:r>
+              <a:rPr lang="en-US" sz="3600" b="1" dirty="0">
                 <a:solidFill>
                   <a:srgbClr val="0F172A"/>
                 </a:solidFill>
               </a:rPr>
-              <a:t>How many of you have written SQL before?</a:t>
-            </a:r>
-          </a:p>
-        </p:txBody>
-      </p:sp>
-      <p:sp>
-        <p:nvSpPr>
-          <p:cNvPr id="201" name="Pain201"/>
+              <a:t>Data is </a:t>
+            </a:r>
+            <a:r>
+              <a:rPr lang="en-US" sz="3600" b="1" dirty="0">
+                <a:solidFill>
+                  <a:srgbClr val="FF0000"/>
+                </a:solidFill>
+              </a:rPr>
+              <a:t>locked</a:t>
+            </a:r>
+            <a:r>
+              <a:rPr lang="en-US" sz="3600" b="1" dirty="0">
+                <a:solidFill>
+                  <a:srgbClr val="0F172A"/>
+                </a:solidFill>
+              </a:rPr>
+              <a:t> behind technical curtains</a:t>
+            </a:r>
+          </a:p>
+        </p:txBody>
+      </p:sp>
+      <p:sp>
+        <p:nvSpPr>
+          <p:cNvPr id="202" name="Pain202"/>
           <p:cNvSpPr/>
           <p:nvPr/>
         </p:nvSpPr>
         <p:spPr>
           <a:xfrm>
-            <a:off x="889000" y="3175000"/>
-            <a:ext cx="5080000" cy="1143000"/>
+            <a:off x="602232" y="4490884"/>
+            <a:ext cx="8143566" cy="1143000"/>
           </a:xfrm>
           <a:prstGeom prst="roundRect">
             <a:avLst>
@@ -13676,10 +13777,10 @@
             <a:r>
               <a:rPr lang="en-US" b="1" dirty="0">
                 <a:solidFill>
-                  <a:srgbClr val="0891B2"/>
-                </a:solidFill>
-              </a:rPr>
-              <a:t>01  </a:t>
+                  <a:srgbClr val="F59E0B"/>
+                </a:solidFill>
+              </a:rPr>
+              <a:t>02  </a:t>
             </a:r>
             <a:r>
               <a:rPr lang="en-US" sz="2400" b="1" dirty="0">
@@ -13687,7 +13788,15 @@
                   <a:srgbClr val="0F172A"/>
                 </a:solidFill>
               </a:rPr>
-              <a:t>Writing SQL is slow</a:t>
+              <a:t>Developers are </a:t>
+            </a:r>
+            <a:r>
+              <a:rPr lang="en-US" sz="2400" b="1" u="sng" dirty="0">
+                <a:solidFill>
+                  <a:srgbClr val="0F172A"/>
+                </a:solidFill>
+              </a:rPr>
+              <a:t>bottleneck</a:t>
             </a:r>
           </a:p>
           <a:p>
@@ -13702,21 +13811,21 @@
                   <a:srgbClr val="475569"/>
                 </a:solidFill>
               </a:rPr>
-              <a:t>Even simple reports take hours</a:t>
-            </a:r>
-          </a:p>
-        </p:txBody>
-      </p:sp>
-      <p:sp>
-        <p:nvSpPr>
-          <p:cNvPr id="202" name="Pain202"/>
+              <a:t>Business waits on engineers</a:t>
+            </a:r>
+          </a:p>
+        </p:txBody>
+      </p:sp>
+      <p:sp>
+        <p:nvSpPr>
+          <p:cNvPr id="203" name="Pain203"/>
           <p:cNvSpPr/>
           <p:nvPr/>
         </p:nvSpPr>
         <p:spPr>
           <a:xfrm>
-            <a:off x="6223000" y="3175000"/>
-            <a:ext cx="5080000" cy="1143000"/>
+            <a:off x="602231" y="1650540"/>
+            <a:ext cx="8143567" cy="1143000"/>
           </a:xfrm>
           <a:prstGeom prst="roundRect">
             <a:avLst>
@@ -13740,10 +13849,10 @@
             <a:r>
               <a:rPr lang="en-US" b="1" dirty="0">
                 <a:solidFill>
-                  <a:srgbClr val="F59E0B"/>
-                </a:solidFill>
-              </a:rPr>
-              <a:t>02  </a:t>
+                  <a:srgbClr val="F43F5E"/>
+                </a:solidFill>
+              </a:rPr>
+              <a:t>01  </a:t>
             </a:r>
             <a:r>
               <a:rPr lang="en-US" sz="2400" b="1" dirty="0">
@@ -13751,7 +13860,15 @@
                   <a:srgbClr val="0F172A"/>
                 </a:solidFill>
               </a:rPr>
-              <a:t>Dev bottleneck</a:t>
+              <a:t>Reporting tools are </a:t>
+            </a:r>
+            <a:r>
+              <a:rPr lang="en-US" sz="2400" b="1" u="sng" dirty="0">
+                <a:solidFill>
+                  <a:srgbClr val="0F172A"/>
+                </a:solidFill>
+              </a:rPr>
+              <a:t>rigid</a:t>
             </a:r>
           </a:p>
           <a:p>
@@ -13766,21 +13883,21 @@
                   <a:srgbClr val="475569"/>
                 </a:solidFill>
               </a:rPr>
-              <a:t>Business waits on engineers</a:t>
-            </a:r>
-          </a:p>
-        </p:txBody>
-      </p:sp>
-      <p:sp>
-        <p:nvSpPr>
-          <p:cNvPr id="203" name="Pain203"/>
+              <a:t>Every new question = new ticket</a:t>
+            </a:r>
+          </a:p>
+        </p:txBody>
+      </p:sp>
+      <p:sp>
+        <p:nvSpPr>
+          <p:cNvPr id="204" name="Pain204"/>
           <p:cNvSpPr/>
           <p:nvPr/>
         </p:nvSpPr>
         <p:spPr>
           <a:xfrm>
-            <a:off x="889000" y="4572000"/>
-            <a:ext cx="5080000" cy="1143000"/>
+            <a:off x="602232" y="3079878"/>
+            <a:ext cx="8143568" cy="1143000"/>
           </a:xfrm>
           <a:prstGeom prst="roundRect">
             <a:avLst>
@@ -13804,7 +13921,7 @@
             <a:r>
               <a:rPr lang="en-US" b="1" dirty="0">
                 <a:solidFill>
-                  <a:srgbClr val="F43F5E"/>
+                  <a:srgbClr val="10B981"/>
                 </a:solidFill>
               </a:rPr>
               <a:t>03  </a:t>
@@ -13815,7 +13932,7 @@
                   <a:srgbClr val="0F172A"/>
                 </a:solidFill>
               </a:rPr>
-              <a:t>Rigid reporting tools</a:t>
+              <a:t>Writing SQL, Page Design, Testing, Deployment</a:t>
             </a:r>
           </a:p>
           <a:p>
@@ -13830,71 +13947,7 @@
                   <a:srgbClr val="475569"/>
                 </a:solidFill>
               </a:rPr>
-              <a:t>Every new question = new ticket</a:t>
-            </a:r>
-          </a:p>
-        </p:txBody>
-      </p:sp>
-      <p:sp>
-        <p:nvSpPr>
-          <p:cNvPr id="204" name="Pain204"/>
-          <p:cNvSpPr/>
-          <p:nvPr/>
-        </p:nvSpPr>
-        <p:spPr>
-          <a:xfrm>
-            <a:off x="6223000" y="4572000"/>
-            <a:ext cx="5080000" cy="1143000"/>
-          </a:xfrm>
-          <a:prstGeom prst="roundRect">
-            <a:avLst>
-              <a:gd name="adj" fmla="val 8000"/>
-            </a:avLst>
-          </a:prstGeom>
-          <a:solidFill>
-            <a:srgbClr val="FFFFFF"/>
-          </a:solidFill>
-          <a:ln w="12700">
-            <a:solidFill>
-              <a:srgbClr val="E2E8F0"/>
-            </a:solidFill>
-          </a:ln>
-        </p:spPr>
-        <p:txBody>
-          <a:bodyPr wrap="square" lIns="180000" tIns="140000" rIns="180000" bIns="140000" anchor="ctr"/>
-          <a:lstStyle/>
-          <a:p>
-            <a:pPr algn="l"/>
-            <a:r>
-              <a:rPr lang="en-US" b="1" dirty="0">
-                <a:solidFill>
-                  <a:srgbClr val="10B981"/>
-                </a:solidFill>
-              </a:rPr>
-              <a:t>04  </a:t>
-            </a:r>
-            <a:r>
-              <a:rPr lang="en-US" sz="2400" b="1" dirty="0">
-                <a:solidFill>
-                  <a:srgbClr val="0F172A"/>
-                </a:solidFill>
-              </a:rPr>
-              <a:t>Data is locked away</a:t>
-            </a:r>
-          </a:p>
-          <a:p>
-            <a:pPr algn="l">
-              <a:spcBef>
-                <a:spcPts val="400"/>
-              </a:spcBef>
-            </a:pPr>
-            <a:r>
-              <a:rPr lang="en-US" dirty="0">
-                <a:solidFill>
-                  <a:srgbClr val="475569"/>
-                </a:solidFill>
-              </a:rPr>
-              <a:t>The value is trapped behind SQL</a:t>
+              <a:t>The real value is trapped behind technical gatekeepers</a:t>
             </a:r>
           </a:p>
         </p:txBody>
@@ -14666,8 +14719,8 @@
         </p:nvSpPr>
         <p:spPr>
           <a:xfrm>
-            <a:off x="948375" y="1968500"/>
-            <a:ext cx="1224000" cy="76200"/>
+            <a:off x="929325" y="1911350"/>
+            <a:ext cx="4752000" cy="76200"/>
           </a:xfrm>
           <a:prstGeom prst="rect">
             <a:avLst/>
@@ -14756,12 +14809,12 @@
         <p:spPr>
           <a:xfrm>
             <a:off x="831850" y="2050663"/>
-            <a:ext cx="2930596" cy="558799"/>
+            <a:ext cx="5016500" cy="558799"/>
           </a:xfrm>
         </p:spPr>
         <p:txBody>
           <a:bodyPr>
-            <a:normAutofit/>
+            <a:normAutofit fontScale="77500" lnSpcReduction="20000"/>
           </a:bodyPr>
           <a:lstStyle/>
           <a:p>
@@ -14774,7 +14827,7 @@
                   <a:srgbClr val="22D3EE"/>
                 </a:solidFill>
               </a:rPr>
-              <a:t>PART 1</a:t>
+              <a:t>CHAT WITH YOUR DATA</a:t>
             </a:r>
           </a:p>
         </p:txBody>

</xml_diff>

<commit_message>
Add Turkish questions to Before-Talk; update PPTX
Add Turkish translations of the existing questions to Before-Talk.txt, correct punctuation on the 'top 3 best-selling songs' line, and add spacing for readability. Presentation.pptx was also updated (binary change).
</commit_message>
<xml_diff>
--- a/Presentation.pptx
+++ b/Presentation.pptx
@@ -218,7 +218,7 @@
           <a:p>
             <a:fld id="{BC660078-77E7-46A7-9649-B3FD62DAD7B9}" type="datetimeFigureOut">
               <a:rPr lang="tr-TR" smtClean="0"/>
-              <a:t>6.05.2026</a:t>
+              <a:t>8.05.2026</a:t>
             </a:fld>
             <a:endParaRPr lang="tr-TR"/>
           </a:p>
@@ -2380,8 +2380,21 @@
                   <a:srgbClr val="0F172A"/>
                 </a:solidFill>
               </a:rPr>
-              <a:t>How many of you have written SQL before? Or create a reporting screen?</a:t>
-            </a:r>
+              <a:t>How many of you create a reporting screen or written SQL before</a:t>
+            </a:r>
+            <a:r>
+              <a:rPr lang="en-US" sz="1200" b="1">
+                <a:solidFill>
+                  <a:srgbClr val="0F172A"/>
+                </a:solidFill>
+              </a:rPr>
+              <a:t>? </a:t>
+            </a:r>
+            <a:endParaRPr lang="en-US" sz="1200" b="1" dirty="0">
+              <a:solidFill>
+                <a:srgbClr val="0F172A"/>
+              </a:solidFill>
+            </a:endParaRPr>
           </a:p>
           <a:p>
             <a:endParaRPr lang="en-US" dirty="0"/>
@@ -3088,7 +3101,7 @@
           <a:p>
             <a:fld id="{3EF59CCF-2F75-48E0-B827-F930E918C137}" type="datetimeFigureOut">
               <a:rPr lang="tr-TR" smtClean="0"/>
-              <a:t>6.05.2026</a:t>
+              <a:t>8.05.2026</a:t>
             </a:fld>
             <a:endParaRPr lang="tr-TR"/>
           </a:p>
@@ -3288,7 +3301,7 @@
           <a:p>
             <a:fld id="{3EF59CCF-2F75-48E0-B827-F930E918C137}" type="datetimeFigureOut">
               <a:rPr lang="tr-TR" smtClean="0"/>
-              <a:t>6.05.2026</a:t>
+              <a:t>8.05.2026</a:t>
             </a:fld>
             <a:endParaRPr lang="tr-TR"/>
           </a:p>
@@ -3498,7 +3511,7 @@
           <a:p>
             <a:fld id="{3EF59CCF-2F75-48E0-B827-F930E918C137}" type="datetimeFigureOut">
               <a:rPr lang="tr-TR" smtClean="0"/>
-              <a:t>6.05.2026</a:t>
+              <a:t>8.05.2026</a:t>
             </a:fld>
             <a:endParaRPr lang="tr-TR"/>
           </a:p>
@@ -3698,7 +3711,7 @@
           <a:p>
             <a:fld id="{3EF59CCF-2F75-48E0-B827-F930E918C137}" type="datetimeFigureOut">
               <a:rPr lang="tr-TR" smtClean="0"/>
-              <a:t>6.05.2026</a:t>
+              <a:t>8.05.2026</a:t>
             </a:fld>
             <a:endParaRPr lang="tr-TR"/>
           </a:p>
@@ -3974,7 +3987,7 @@
           <a:p>
             <a:fld id="{3EF59CCF-2F75-48E0-B827-F930E918C137}" type="datetimeFigureOut">
               <a:rPr lang="tr-TR" smtClean="0"/>
-              <a:t>6.05.2026</a:t>
+              <a:t>8.05.2026</a:t>
             </a:fld>
             <a:endParaRPr lang="tr-TR"/>
           </a:p>
@@ -4242,7 +4255,7 @@
           <a:p>
             <a:fld id="{3EF59CCF-2F75-48E0-B827-F930E918C137}" type="datetimeFigureOut">
               <a:rPr lang="tr-TR" smtClean="0"/>
-              <a:t>6.05.2026</a:t>
+              <a:t>8.05.2026</a:t>
             </a:fld>
             <a:endParaRPr lang="tr-TR"/>
           </a:p>
@@ -4657,7 +4670,7 @@
           <a:p>
             <a:fld id="{3EF59CCF-2F75-48E0-B827-F930E918C137}" type="datetimeFigureOut">
               <a:rPr lang="tr-TR" smtClean="0"/>
-              <a:t>6.05.2026</a:t>
+              <a:t>8.05.2026</a:t>
             </a:fld>
             <a:endParaRPr lang="tr-TR"/>
           </a:p>
@@ -4799,7 +4812,7 @@
           <a:p>
             <a:fld id="{3EF59CCF-2F75-48E0-B827-F930E918C137}" type="datetimeFigureOut">
               <a:rPr lang="tr-TR" smtClean="0"/>
-              <a:t>6.05.2026</a:t>
+              <a:t>8.05.2026</a:t>
             </a:fld>
             <a:endParaRPr lang="tr-TR"/>
           </a:p>
@@ -4912,7 +4925,7 @@
           <a:p>
             <a:fld id="{3EF59CCF-2F75-48E0-B827-F930E918C137}" type="datetimeFigureOut">
               <a:rPr lang="tr-TR" smtClean="0"/>
-              <a:t>6.05.2026</a:t>
+              <a:t>8.05.2026</a:t>
             </a:fld>
             <a:endParaRPr lang="tr-TR"/>
           </a:p>
@@ -5225,7 +5238,7 @@
           <a:p>
             <a:fld id="{3EF59CCF-2F75-48E0-B827-F930E918C137}" type="datetimeFigureOut">
               <a:rPr lang="tr-TR" smtClean="0"/>
-              <a:t>6.05.2026</a:t>
+              <a:t>8.05.2026</a:t>
             </a:fld>
             <a:endParaRPr lang="tr-TR"/>
           </a:p>
@@ -5514,7 +5527,7 @@
           <a:p>
             <a:fld id="{3EF59CCF-2F75-48E0-B827-F930E918C137}" type="datetimeFigureOut">
               <a:rPr lang="tr-TR" smtClean="0"/>
-              <a:t>6.05.2026</a:t>
+              <a:t>8.05.2026</a:t>
             </a:fld>
             <a:endParaRPr lang="tr-TR"/>
           </a:p>
@@ -5760,7 +5773,7 @@
           <a:p>
             <a:fld id="{3EF59CCF-2F75-48E0-B827-F930E918C137}" type="datetimeFigureOut">
               <a:rPr lang="tr-TR" smtClean="0"/>
-              <a:t>6.05.2026</a:t>
+              <a:t>8.05.2026</a:t>
             </a:fld>
             <a:endParaRPr lang="tr-TR"/>
           </a:p>
@@ -13055,36 +13068,6 @@
           </p:txBody>
         </p:sp>
       </p:grpSp>
-      <p:pic>
-        <p:nvPicPr>
-          <p:cNvPr id="5" name="Picture 4">
-            <a:extLst>
-              <a:ext uri="{FF2B5EF4-FFF2-40B4-BE49-F238E27FC236}">
-                <a16:creationId xmlns:a16="http://schemas.microsoft.com/office/drawing/2014/main" id="{95D01CF5-3779-C47E-5AA7-7E0126629325}"/>
-              </a:ext>
-            </a:extLst>
-          </p:cNvPr>
-          <p:cNvPicPr>
-            <a:picLocks noChangeAspect="1"/>
-          </p:cNvPicPr>
-          <p:nvPr/>
-        </p:nvPicPr>
-        <p:blipFill>
-          <a:blip r:embed="rId3"/>
-          <a:stretch>
-            <a:fillRect/>
-          </a:stretch>
-        </p:blipFill>
-        <p:spPr>
-          <a:xfrm>
-            <a:off x="9251318" y="4787580"/>
-            <a:ext cx="1735996" cy="1751683"/>
-          </a:xfrm>
-          <a:prstGeom prst="rect">
-            <a:avLst/>
-          </a:prstGeom>
-        </p:spPr>
-      </p:pic>
       <p:sp>
         <p:nvSpPr>
           <p:cNvPr id="7" name="TextBox 6">
@@ -13375,8 +13358,8 @@
         </p:nvSpPr>
         <p:spPr>
           <a:xfrm>
-            <a:off x="5884853" y="4643252"/>
-            <a:ext cx="5277952" cy="1995054"/>
+            <a:off x="5884852" y="4643252"/>
+            <a:ext cx="5415325" cy="1995054"/>
           </a:xfrm>
           <a:prstGeom prst="roundRect">
             <a:avLst/>
@@ -13415,6 +13398,36 @@
           </a:p>
         </p:txBody>
       </p:sp>
+      <p:pic>
+        <p:nvPicPr>
+          <p:cNvPr id="10" name="Picture 9">
+            <a:extLst>
+              <a:ext uri="{FF2B5EF4-FFF2-40B4-BE49-F238E27FC236}">
+                <a16:creationId xmlns:a16="http://schemas.microsoft.com/office/drawing/2014/main" id="{D938F68E-AD3D-20B3-D1A3-233E8E7B77F5}"/>
+              </a:ext>
+            </a:extLst>
+          </p:cNvPr>
+          <p:cNvPicPr>
+            <a:picLocks noChangeAspect="1"/>
+          </p:cNvPicPr>
+          <p:nvPr/>
+        </p:nvPicPr>
+        <p:blipFill>
+          <a:blip r:embed="rId3"/>
+          <a:stretch>
+            <a:fillRect/>
+          </a:stretch>
+        </p:blipFill>
+        <p:spPr>
+          <a:xfrm>
+            <a:off x="9265759" y="4724017"/>
+            <a:ext cx="1783770" cy="1837823"/>
+          </a:xfrm>
+          <a:prstGeom prst="rect">
+            <a:avLst/>
+          </a:prstGeom>
+        </p:spPr>
+      </p:pic>
     </p:spTree>
     <p:extLst>
       <p:ext uri="{BB962C8B-B14F-4D97-AF65-F5344CB8AC3E}">
@@ -15724,9 +15737,6 @@
                     <p:cTn id="3" fill="hold">
                       <p:stCondLst>
                         <p:cond delay="indefinite"/>
-                        <p:cond evt="onBegin" delay="0">
-                          <p:tn val="2"/>
-                        </p:cond>
                       </p:stCondLst>
                       <p:childTnLst>
                         <p:par>
@@ -15736,9 +15746,9 @@
                             </p:stCondLst>
                             <p:childTnLst>
                               <p:par>
-                                <p:cTn id="5" presetID="2" presetClass="entr" presetSubtype="2" fill="hold" nodeType="withEffect">
+                                <p:cTn id="5" presetID="2" presetClass="entr" presetSubtype="2" fill="hold" nodeType="clickEffect">
                                   <p:stCondLst>
-                                    <p:cond delay="10000"/>
+                                    <p:cond delay="0"/>
                                   </p:stCondLst>
                                   <p:childTnLst>
                                     <p:set>
@@ -15761,7 +15771,7 @@
                                     </p:set>
                                     <p:anim calcmode="lin" valueType="num">
                                       <p:cBhvr additive="base">
-                                        <p:cTn id="7" dur="1000" fill="hold"/>
+                                        <p:cTn id="7" dur="500" fill="hold"/>
                                         <p:tgtEl>
                                           <p:spTgt spid="7"/>
                                         </p:tgtEl>
@@ -15784,7 +15794,7 @@
                                     </p:anim>
                                     <p:anim calcmode="lin" valueType="num">
                                       <p:cBhvr additive="base">
-                                        <p:cTn id="8" dur="1000" fill="hold"/>
+                                        <p:cTn id="8" dur="500" fill="hold"/>
                                         <p:tgtEl>
                                           <p:spTgt spid="7"/>
                                         </p:tgtEl>
@@ -16241,8 +16251,8 @@
         </p:nvSpPr>
         <p:spPr>
           <a:xfrm>
-            <a:off x="635000" y="5720834"/>
-            <a:ext cx="5588000" cy="400110"/>
+            <a:off x="406400" y="5720834"/>
+            <a:ext cx="11270938" cy="400110"/>
           </a:xfrm>
           <a:prstGeom prst="rect">
             <a:avLst/>
@@ -16255,7 +16265,7 @@
           </a:bodyPr>
           <a:lstStyle/>
           <a:p>
-            <a:pPr>
+            <a:pPr algn="ctr">
               <a:spcBef>
                 <a:spcPts val="800"/>
               </a:spcBef>

</xml_diff>